<commit_message>
Segment rankers line up on each segment's average; parts $ per RO off the Close grids; retention wording
Co-Authored-By: Claude Opus 5.5 <noreply@anthropic.com>
Claude-Session: https://claude.ai/code/session_01Xa4nFVxuQGXmHARGph9WhS
</commit_message>
<xml_diff>
--- a/day2-deck/decks/Luxury Split Options - Review.pptx
+++ b/day2-deck/decks/Luxury Split Options - Review.pptx
@@ -1361,7 +1361,7 @@
                 <a:ea typeface="Inter" pitchFamily="34" charset="-122"/>
                 <a:cs typeface="Inter" pitchFamily="34" charset="-120"/>
               </a:rPr>
-              <a:t>Each segment ranked on its own. Navy tick = the segment average; green at or above it.</a:t>
+              <a:t>Each segment ranked on its own. Navy line = the segment average; green at or above it.</a:t>
             </a:r>
             <a:endParaRPr lang="en-US" sz="1400" dirty="0"/>
           </a:p>
@@ -1513,7 +1513,7 @@
         <p:spPr>
           <a:xfrm>
             <a:off x="3008376" y="2436622"/>
-            <a:ext cx="1691640" cy="104140"/>
+            <a:ext cx="1457852" cy="104140"/>
           </a:xfrm>
           <a:prstGeom prst="rect">
             <a:avLst/>
@@ -1526,7 +1526,27 @@
       </p:sp>
       <p:sp>
         <p:nvSpPr>
-          <p:cNvPr id="17" name="Text 15"/>
+          <p:cNvPr id="17" name="Shape 15"/>
+          <p:cNvSpPr/>
+          <p:nvPr/>
+        </p:nvSpPr>
+        <p:spPr>
+          <a:xfrm>
+            <a:off x="4189582" y="2405380"/>
+            <a:ext cx="21946" cy="166624"/>
+          </a:xfrm>
+          <a:prstGeom prst="rect">
+            <a:avLst/>
+          </a:prstGeom>
+          <a:solidFill>
+            <a:srgbClr val="0B2C4A"/>
+          </a:solidFill>
+          <a:ln/>
+        </p:spPr>
+      </p:sp>
+      <p:sp>
+        <p:nvSpPr>
+          <p:cNvPr id="18" name="Text 16"/>
           <p:cNvSpPr txBox="1"/>
           <p:nvPr/>
         </p:nvSpPr>
@@ -1565,7 +1585,7 @@
       </p:sp>
       <p:sp>
         <p:nvSpPr>
-          <p:cNvPr id="18" name="Text 16"/>
+          <p:cNvPr id="19" name="Text 17"/>
           <p:cNvSpPr txBox="1"/>
           <p:nvPr/>
         </p:nvSpPr>
@@ -1604,7 +1624,7 @@
       </p:sp>
       <p:sp>
         <p:nvSpPr>
-          <p:cNvPr id="19" name="Text 17"/>
+          <p:cNvPr id="20" name="Text 18"/>
           <p:cNvSpPr txBox="1"/>
           <p:nvPr/>
         </p:nvSpPr>
@@ -1643,14 +1663,14 @@
       </p:sp>
       <p:sp>
         <p:nvSpPr>
-          <p:cNvPr id="20" name="Shape 18"/>
+          <p:cNvPr id="21" name="Shape 19"/>
           <p:cNvSpPr/>
           <p:nvPr/>
         </p:nvSpPr>
         <p:spPr>
           <a:xfrm>
             <a:off x="3008376" y="2644902"/>
-            <a:ext cx="1493088" cy="104140"/>
+            <a:ext cx="1286740" cy="104140"/>
           </a:xfrm>
           <a:prstGeom prst="rect">
             <a:avLst/>
@@ -1663,7 +1683,27 @@
       </p:sp>
       <p:sp>
         <p:nvSpPr>
-          <p:cNvPr id="21" name="Text 19"/>
+          <p:cNvPr id="22" name="Shape 20"/>
+          <p:cNvSpPr/>
+          <p:nvPr/>
+        </p:nvSpPr>
+        <p:spPr>
+          <a:xfrm>
+            <a:off x="4189582" y="2613660"/>
+            <a:ext cx="21946" cy="166624"/>
+          </a:xfrm>
+          <a:prstGeom prst="rect">
+            <a:avLst/>
+          </a:prstGeom>
+          <a:solidFill>
+            <a:srgbClr val="0B2C4A"/>
+          </a:solidFill>
+          <a:ln/>
+        </p:spPr>
+      </p:sp>
+      <p:sp>
+        <p:nvSpPr>
+          <p:cNvPr id="23" name="Text 21"/>
           <p:cNvSpPr txBox="1"/>
           <p:nvPr/>
         </p:nvSpPr>
@@ -1702,7 +1742,7 @@
       </p:sp>
       <p:sp>
         <p:nvSpPr>
-          <p:cNvPr id="22" name="Text 20"/>
+          <p:cNvPr id="24" name="Text 22"/>
           <p:cNvSpPr txBox="1"/>
           <p:nvPr/>
         </p:nvSpPr>
@@ -1741,7 +1781,7 @@
       </p:sp>
       <p:sp>
         <p:nvSpPr>
-          <p:cNvPr id="23" name="Text 21"/>
+          <p:cNvPr id="25" name="Text 23"/>
           <p:cNvSpPr txBox="1"/>
           <p:nvPr/>
         </p:nvSpPr>
@@ -1780,14 +1820,14 @@
       </p:sp>
       <p:sp>
         <p:nvSpPr>
-          <p:cNvPr id="24" name="Shape 22"/>
+          <p:cNvPr id="26" name="Shape 24"/>
           <p:cNvSpPr/>
           <p:nvPr/>
         </p:nvSpPr>
         <p:spPr>
           <a:xfrm>
             <a:off x="3008376" y="2853182"/>
-            <a:ext cx="1489826" cy="104140"/>
+            <a:ext cx="1283929" cy="104140"/>
           </a:xfrm>
           <a:prstGeom prst="rect">
             <a:avLst/>
@@ -1800,7 +1840,27 @@
       </p:sp>
       <p:sp>
         <p:nvSpPr>
-          <p:cNvPr id="25" name="Text 23"/>
+          <p:cNvPr id="27" name="Shape 25"/>
+          <p:cNvSpPr/>
+          <p:nvPr/>
+        </p:nvSpPr>
+        <p:spPr>
+          <a:xfrm>
+            <a:off x="4189582" y="2821940"/>
+            <a:ext cx="21946" cy="166624"/>
+          </a:xfrm>
+          <a:prstGeom prst="rect">
+            <a:avLst/>
+          </a:prstGeom>
+          <a:solidFill>
+            <a:srgbClr val="0B2C4A"/>
+          </a:solidFill>
+          <a:ln/>
+        </p:spPr>
+      </p:sp>
+      <p:sp>
+        <p:nvSpPr>
+          <p:cNvPr id="28" name="Text 26"/>
           <p:cNvSpPr txBox="1"/>
           <p:nvPr/>
         </p:nvSpPr>
@@ -1839,7 +1899,7 @@
       </p:sp>
       <p:sp>
         <p:nvSpPr>
-          <p:cNvPr id="26" name="Text 24"/>
+          <p:cNvPr id="29" name="Text 27"/>
           <p:cNvSpPr txBox="1"/>
           <p:nvPr/>
         </p:nvSpPr>
@@ -1878,7 +1938,7 @@
       </p:sp>
       <p:sp>
         <p:nvSpPr>
-          <p:cNvPr id="27" name="Text 25"/>
+          <p:cNvPr id="30" name="Text 28"/>
           <p:cNvSpPr txBox="1"/>
           <p:nvPr/>
         </p:nvSpPr>
@@ -1917,14 +1977,14 @@
       </p:sp>
       <p:sp>
         <p:nvSpPr>
-          <p:cNvPr id="28" name="Shape 26"/>
+          <p:cNvPr id="31" name="Shape 29"/>
           <p:cNvSpPr/>
           <p:nvPr/>
         </p:nvSpPr>
         <p:spPr>
           <a:xfrm>
             <a:off x="3008376" y="3061462"/>
-            <a:ext cx="1485001" cy="104140"/>
+            <a:ext cx="1279771" cy="104140"/>
           </a:xfrm>
           <a:prstGeom prst="rect">
             <a:avLst/>
@@ -1937,7 +1997,27 @@
       </p:sp>
       <p:sp>
         <p:nvSpPr>
-          <p:cNvPr id="29" name="Text 27"/>
+          <p:cNvPr id="32" name="Shape 30"/>
+          <p:cNvSpPr/>
+          <p:nvPr/>
+        </p:nvSpPr>
+        <p:spPr>
+          <a:xfrm>
+            <a:off x="4189582" y="3030220"/>
+            <a:ext cx="21946" cy="166624"/>
+          </a:xfrm>
+          <a:prstGeom prst="rect">
+            <a:avLst/>
+          </a:prstGeom>
+          <a:solidFill>
+            <a:srgbClr val="0B2C4A"/>
+          </a:solidFill>
+          <a:ln/>
+        </p:spPr>
+      </p:sp>
+      <p:sp>
+        <p:nvSpPr>
+          <p:cNvPr id="33" name="Text 31"/>
           <p:cNvSpPr txBox="1"/>
           <p:nvPr/>
         </p:nvSpPr>
@@ -1976,7 +2056,7 @@
       </p:sp>
       <p:sp>
         <p:nvSpPr>
-          <p:cNvPr id="30" name="Text 28"/>
+          <p:cNvPr id="34" name="Text 32"/>
           <p:cNvSpPr txBox="1"/>
           <p:nvPr/>
         </p:nvSpPr>
@@ -2015,7 +2095,7 @@
       </p:sp>
       <p:sp>
         <p:nvSpPr>
-          <p:cNvPr id="31" name="Text 29"/>
+          <p:cNvPr id="35" name="Text 33"/>
           <p:cNvSpPr txBox="1"/>
           <p:nvPr/>
         </p:nvSpPr>
@@ -2054,14 +2134,14 @@
       </p:sp>
       <p:sp>
         <p:nvSpPr>
-          <p:cNvPr id="32" name="Shape 30"/>
+          <p:cNvPr id="36" name="Shape 34"/>
           <p:cNvSpPr/>
           <p:nvPr/>
         </p:nvSpPr>
         <p:spPr>
           <a:xfrm>
             <a:off x="3008376" y="3269742"/>
-            <a:ext cx="1482885" cy="104140"/>
+            <a:ext cx="1277948" cy="104140"/>
           </a:xfrm>
           <a:prstGeom prst="rect">
             <a:avLst/>
@@ -2074,7 +2154,27 @@
       </p:sp>
       <p:sp>
         <p:nvSpPr>
-          <p:cNvPr id="33" name="Text 31"/>
+          <p:cNvPr id="37" name="Shape 35"/>
+          <p:cNvSpPr/>
+          <p:nvPr/>
+        </p:nvSpPr>
+        <p:spPr>
+          <a:xfrm>
+            <a:off x="4189582" y="3238500"/>
+            <a:ext cx="21946" cy="166624"/>
+          </a:xfrm>
+          <a:prstGeom prst="rect">
+            <a:avLst/>
+          </a:prstGeom>
+          <a:solidFill>
+            <a:srgbClr val="0B2C4A"/>
+          </a:solidFill>
+          <a:ln/>
+        </p:spPr>
+      </p:sp>
+      <p:sp>
+        <p:nvSpPr>
+          <p:cNvPr id="38" name="Text 36"/>
           <p:cNvSpPr txBox="1"/>
           <p:nvPr/>
         </p:nvSpPr>
@@ -2113,7 +2213,7 @@
       </p:sp>
       <p:sp>
         <p:nvSpPr>
-          <p:cNvPr id="34" name="Text 32"/>
+          <p:cNvPr id="39" name="Text 37"/>
           <p:cNvSpPr txBox="1"/>
           <p:nvPr/>
         </p:nvSpPr>
@@ -2152,7 +2252,7 @@
       </p:sp>
       <p:sp>
         <p:nvSpPr>
-          <p:cNvPr id="35" name="Text 33"/>
+          <p:cNvPr id="40" name="Text 38"/>
           <p:cNvSpPr txBox="1"/>
           <p:nvPr/>
         </p:nvSpPr>
@@ -2191,14 +2291,14 @@
       </p:sp>
       <p:sp>
         <p:nvSpPr>
-          <p:cNvPr id="36" name="Shape 34"/>
+          <p:cNvPr id="41" name="Shape 39"/>
           <p:cNvSpPr/>
           <p:nvPr/>
         </p:nvSpPr>
         <p:spPr>
           <a:xfrm>
             <a:off x="3008376" y="3478022"/>
-            <a:ext cx="1410841" cy="104140"/>
+            <a:ext cx="1215860" cy="104140"/>
           </a:xfrm>
           <a:prstGeom prst="rect">
             <a:avLst/>
@@ -2211,7 +2311,27 @@
       </p:sp>
       <p:sp>
         <p:nvSpPr>
-          <p:cNvPr id="37" name="Text 35"/>
+          <p:cNvPr id="42" name="Shape 40"/>
+          <p:cNvSpPr/>
+          <p:nvPr/>
+        </p:nvSpPr>
+        <p:spPr>
+          <a:xfrm>
+            <a:off x="4189582" y="3446780"/>
+            <a:ext cx="21946" cy="166624"/>
+          </a:xfrm>
+          <a:prstGeom prst="rect">
+            <a:avLst/>
+          </a:prstGeom>
+          <a:solidFill>
+            <a:srgbClr val="0B2C4A"/>
+          </a:solidFill>
+          <a:ln/>
+        </p:spPr>
+      </p:sp>
+      <p:sp>
+        <p:nvSpPr>
+          <p:cNvPr id="43" name="Text 41"/>
           <p:cNvSpPr txBox="1"/>
           <p:nvPr/>
         </p:nvSpPr>
@@ -2250,7 +2370,7 @@
       </p:sp>
       <p:sp>
         <p:nvSpPr>
-          <p:cNvPr id="38" name="Text 36"/>
+          <p:cNvPr id="44" name="Text 42"/>
           <p:cNvSpPr txBox="1"/>
           <p:nvPr/>
         </p:nvSpPr>
@@ -2289,7 +2409,7 @@
       </p:sp>
       <p:sp>
         <p:nvSpPr>
-          <p:cNvPr id="39" name="Text 37"/>
+          <p:cNvPr id="45" name="Text 43"/>
           <p:cNvSpPr txBox="1"/>
           <p:nvPr/>
         </p:nvSpPr>
@@ -2328,14 +2448,14 @@
       </p:sp>
       <p:sp>
         <p:nvSpPr>
-          <p:cNvPr id="40" name="Shape 38"/>
+          <p:cNvPr id="46" name="Shape 44"/>
           <p:cNvSpPr/>
           <p:nvPr/>
         </p:nvSpPr>
         <p:spPr>
           <a:xfrm>
             <a:off x="3008376" y="3686302"/>
-            <a:ext cx="1227728" cy="104140"/>
+            <a:ext cx="1058054" cy="104140"/>
           </a:xfrm>
           <a:prstGeom prst="rect">
             <a:avLst/>
@@ -2348,7 +2468,27 @@
       </p:sp>
       <p:sp>
         <p:nvSpPr>
-          <p:cNvPr id="41" name="Text 39"/>
+          <p:cNvPr id="47" name="Shape 45"/>
+          <p:cNvSpPr/>
+          <p:nvPr/>
+        </p:nvSpPr>
+        <p:spPr>
+          <a:xfrm>
+            <a:off x="4189582" y="3655060"/>
+            <a:ext cx="21946" cy="166624"/>
+          </a:xfrm>
+          <a:prstGeom prst="rect">
+            <a:avLst/>
+          </a:prstGeom>
+          <a:solidFill>
+            <a:srgbClr val="0B2C4A"/>
+          </a:solidFill>
+          <a:ln/>
+        </p:spPr>
+      </p:sp>
+      <p:sp>
+        <p:nvSpPr>
+          <p:cNvPr id="48" name="Text 46"/>
           <p:cNvSpPr txBox="1"/>
           <p:nvPr/>
         </p:nvSpPr>
@@ -2387,7 +2527,7 @@
       </p:sp>
       <p:sp>
         <p:nvSpPr>
-          <p:cNvPr id="42" name="Text 40"/>
+          <p:cNvPr id="49" name="Text 47"/>
           <p:cNvSpPr txBox="1"/>
           <p:nvPr/>
         </p:nvSpPr>
@@ -2426,7 +2566,7 @@
       </p:sp>
       <p:sp>
         <p:nvSpPr>
-          <p:cNvPr id="43" name="Text 41"/>
+          <p:cNvPr id="50" name="Text 48"/>
           <p:cNvSpPr txBox="1"/>
           <p:nvPr/>
         </p:nvSpPr>
@@ -2465,14 +2605,14 @@
       </p:sp>
       <p:sp>
         <p:nvSpPr>
-          <p:cNvPr id="44" name="Shape 42"/>
+          <p:cNvPr id="51" name="Shape 49"/>
           <p:cNvSpPr/>
           <p:nvPr/>
         </p:nvSpPr>
         <p:spPr>
           <a:xfrm>
             <a:off x="3008376" y="3894582"/>
-            <a:ext cx="1079883" cy="104140"/>
+            <a:ext cx="930641" cy="104140"/>
           </a:xfrm>
           <a:prstGeom prst="rect">
             <a:avLst/>
@@ -2485,7 +2625,27 @@
       </p:sp>
       <p:sp>
         <p:nvSpPr>
-          <p:cNvPr id="45" name="Text 43"/>
+          <p:cNvPr id="52" name="Shape 50"/>
+          <p:cNvSpPr/>
+          <p:nvPr/>
+        </p:nvSpPr>
+        <p:spPr>
+          <a:xfrm>
+            <a:off x="4189582" y="3863340"/>
+            <a:ext cx="21946" cy="166624"/>
+          </a:xfrm>
+          <a:prstGeom prst="rect">
+            <a:avLst/>
+          </a:prstGeom>
+          <a:solidFill>
+            <a:srgbClr val="0B2C4A"/>
+          </a:solidFill>
+          <a:ln/>
+        </p:spPr>
+      </p:sp>
+      <p:sp>
+        <p:nvSpPr>
+          <p:cNvPr id="53" name="Text 51"/>
           <p:cNvSpPr txBox="1"/>
           <p:nvPr/>
         </p:nvSpPr>
@@ -2524,7 +2684,7 @@
       </p:sp>
       <p:sp>
         <p:nvSpPr>
-          <p:cNvPr id="46" name="Text 44"/>
+          <p:cNvPr id="54" name="Text 52"/>
           <p:cNvSpPr txBox="1"/>
           <p:nvPr/>
         </p:nvSpPr>
@@ -2563,7 +2723,7 @@
       </p:sp>
       <p:sp>
         <p:nvSpPr>
-          <p:cNvPr id="47" name="Text 45"/>
+          <p:cNvPr id="55" name="Text 53"/>
           <p:cNvSpPr txBox="1"/>
           <p:nvPr/>
         </p:nvSpPr>
@@ -2602,14 +2762,14 @@
       </p:sp>
       <p:sp>
         <p:nvSpPr>
-          <p:cNvPr id="48" name="Shape 46"/>
+          <p:cNvPr id="56" name="Shape 54"/>
           <p:cNvSpPr/>
           <p:nvPr/>
         </p:nvSpPr>
         <p:spPr>
           <a:xfrm>
             <a:off x="3008376" y="4102862"/>
-            <a:ext cx="1064787" cy="104140"/>
+            <a:ext cx="917631" cy="104140"/>
           </a:xfrm>
           <a:prstGeom prst="rect">
             <a:avLst/>
@@ -2622,7 +2782,27 @@
       </p:sp>
       <p:sp>
         <p:nvSpPr>
-          <p:cNvPr id="49" name="Text 47"/>
+          <p:cNvPr id="57" name="Shape 55"/>
+          <p:cNvSpPr/>
+          <p:nvPr/>
+        </p:nvSpPr>
+        <p:spPr>
+          <a:xfrm>
+            <a:off x="4189582" y="4071620"/>
+            <a:ext cx="21946" cy="166624"/>
+          </a:xfrm>
+          <a:prstGeom prst="rect">
+            <a:avLst/>
+          </a:prstGeom>
+          <a:solidFill>
+            <a:srgbClr val="0B2C4A"/>
+          </a:solidFill>
+          <a:ln/>
+        </p:spPr>
+      </p:sp>
+      <p:sp>
+        <p:nvSpPr>
+          <p:cNvPr id="58" name="Text 56"/>
           <p:cNvSpPr txBox="1"/>
           <p:nvPr/>
         </p:nvSpPr>
@@ -2661,7 +2841,7 @@
       </p:sp>
       <p:sp>
         <p:nvSpPr>
-          <p:cNvPr id="50" name="Text 48"/>
+          <p:cNvPr id="59" name="Text 57"/>
           <p:cNvSpPr txBox="1"/>
           <p:nvPr/>
         </p:nvSpPr>
@@ -2700,7 +2880,7 @@
       </p:sp>
       <p:sp>
         <p:nvSpPr>
-          <p:cNvPr id="51" name="Shape 49"/>
+          <p:cNvPr id="60" name="Shape 58"/>
           <p:cNvSpPr/>
           <p:nvPr/>
         </p:nvSpPr>
@@ -2720,7 +2900,7 @@
       </p:sp>
       <p:sp>
         <p:nvSpPr>
-          <p:cNvPr id="52" name="Text 50"/>
+          <p:cNvPr id="61" name="Text 59"/>
           <p:cNvSpPr txBox="1"/>
           <p:nvPr/>
         </p:nvSpPr>
@@ -2759,7 +2939,7 @@
       </p:sp>
       <p:sp>
         <p:nvSpPr>
-          <p:cNvPr id="53" name="Text 51"/>
+          <p:cNvPr id="62" name="Text 60"/>
           <p:cNvSpPr txBox="1"/>
           <p:nvPr/>
         </p:nvSpPr>
@@ -2798,14 +2978,14 @@
       </p:sp>
       <p:sp>
         <p:nvSpPr>
-          <p:cNvPr id="54" name="Shape 52"/>
+          <p:cNvPr id="63" name="Shape 61"/>
           <p:cNvSpPr/>
           <p:nvPr/>
         </p:nvSpPr>
         <p:spPr>
           <a:xfrm>
             <a:off x="3008376" y="4519422"/>
-            <a:ext cx="1337061" cy="104140"/>
+            <a:ext cx="1658471" cy="104140"/>
           </a:xfrm>
           <a:prstGeom prst="rect">
             <a:avLst/>
@@ -2818,7 +2998,27 @@
       </p:sp>
       <p:sp>
         <p:nvSpPr>
-          <p:cNvPr id="55" name="Text 53"/>
+          <p:cNvPr id="64" name="Shape 62"/>
+          <p:cNvSpPr/>
+          <p:nvPr/>
+        </p:nvSpPr>
+        <p:spPr>
+          <a:xfrm>
+            <a:off x="4189582" y="4488180"/>
+            <a:ext cx="21946" cy="166624"/>
+          </a:xfrm>
+          <a:prstGeom prst="rect">
+            <a:avLst/>
+          </a:prstGeom>
+          <a:solidFill>
+            <a:srgbClr val="0B2C4A"/>
+          </a:solidFill>
+          <a:ln/>
+        </p:spPr>
+      </p:sp>
+      <p:sp>
+        <p:nvSpPr>
+          <p:cNvPr id="65" name="Text 63"/>
           <p:cNvSpPr txBox="1"/>
           <p:nvPr/>
         </p:nvSpPr>
@@ -2857,7 +3057,7 @@
       </p:sp>
       <p:sp>
         <p:nvSpPr>
-          <p:cNvPr id="56" name="Text 54"/>
+          <p:cNvPr id="66" name="Text 64"/>
           <p:cNvSpPr txBox="1"/>
           <p:nvPr/>
         </p:nvSpPr>
@@ -2896,7 +3096,7 @@
       </p:sp>
       <p:sp>
         <p:nvSpPr>
-          <p:cNvPr id="57" name="Text 55"/>
+          <p:cNvPr id="67" name="Text 65"/>
           <p:cNvSpPr txBox="1"/>
           <p:nvPr/>
         </p:nvSpPr>
@@ -2935,14 +3135,14 @@
       </p:sp>
       <p:sp>
         <p:nvSpPr>
-          <p:cNvPr id="58" name="Shape 56"/>
+          <p:cNvPr id="68" name="Shape 66"/>
           <p:cNvSpPr/>
           <p:nvPr/>
         </p:nvSpPr>
         <p:spPr>
           <a:xfrm>
             <a:off x="3008376" y="4727702"/>
-            <a:ext cx="1117263" cy="104140"/>
+            <a:ext cx="1385836" cy="104140"/>
           </a:xfrm>
           <a:prstGeom prst="rect">
             <a:avLst/>
@@ -2955,7 +3155,27 @@
       </p:sp>
       <p:sp>
         <p:nvSpPr>
-          <p:cNvPr id="59" name="Text 57"/>
+          <p:cNvPr id="69" name="Shape 67"/>
+          <p:cNvSpPr/>
+          <p:nvPr/>
+        </p:nvSpPr>
+        <p:spPr>
+          <a:xfrm>
+            <a:off x="4189582" y="4696460"/>
+            <a:ext cx="21946" cy="166624"/>
+          </a:xfrm>
+          <a:prstGeom prst="rect">
+            <a:avLst/>
+          </a:prstGeom>
+          <a:solidFill>
+            <a:srgbClr val="0B2C4A"/>
+          </a:solidFill>
+          <a:ln/>
+        </p:spPr>
+      </p:sp>
+      <p:sp>
+        <p:nvSpPr>
+          <p:cNvPr id="70" name="Text 68"/>
           <p:cNvSpPr txBox="1"/>
           <p:nvPr/>
         </p:nvSpPr>
@@ -2994,7 +3214,7 @@
       </p:sp>
       <p:sp>
         <p:nvSpPr>
-          <p:cNvPr id="60" name="Text 58"/>
+          <p:cNvPr id="71" name="Text 69"/>
           <p:cNvSpPr txBox="1"/>
           <p:nvPr/>
         </p:nvSpPr>
@@ -3033,7 +3253,7 @@
       </p:sp>
       <p:sp>
         <p:nvSpPr>
-          <p:cNvPr id="61" name="Text 59"/>
+          <p:cNvPr id="72" name="Text 70"/>
           <p:cNvSpPr txBox="1"/>
           <p:nvPr/>
         </p:nvSpPr>
@@ -3072,14 +3292,14 @@
       </p:sp>
       <p:sp>
         <p:nvSpPr>
-          <p:cNvPr id="62" name="Shape 60"/>
+          <p:cNvPr id="73" name="Shape 71"/>
           <p:cNvSpPr/>
           <p:nvPr/>
         </p:nvSpPr>
         <p:spPr>
           <a:xfrm>
             <a:off x="3008376" y="4935982"/>
-            <a:ext cx="1057221" cy="104140"/>
+            <a:ext cx="1311361" cy="104140"/>
           </a:xfrm>
           <a:prstGeom prst="rect">
             <a:avLst/>
@@ -3092,7 +3312,27 @@
       </p:sp>
       <p:sp>
         <p:nvSpPr>
-          <p:cNvPr id="63" name="Text 61"/>
+          <p:cNvPr id="74" name="Shape 72"/>
+          <p:cNvSpPr/>
+          <p:nvPr/>
+        </p:nvSpPr>
+        <p:spPr>
+          <a:xfrm>
+            <a:off x="4189582" y="4904740"/>
+            <a:ext cx="21946" cy="166624"/>
+          </a:xfrm>
+          <a:prstGeom prst="rect">
+            <a:avLst/>
+          </a:prstGeom>
+          <a:solidFill>
+            <a:srgbClr val="0B2C4A"/>
+          </a:solidFill>
+          <a:ln/>
+        </p:spPr>
+      </p:sp>
+      <p:sp>
+        <p:nvSpPr>
+          <p:cNvPr id="75" name="Text 73"/>
           <p:cNvSpPr txBox="1"/>
           <p:nvPr/>
         </p:nvSpPr>
@@ -3131,7 +3371,7 @@
       </p:sp>
       <p:sp>
         <p:nvSpPr>
-          <p:cNvPr id="64" name="Text 62"/>
+          <p:cNvPr id="76" name="Text 74"/>
           <p:cNvSpPr txBox="1"/>
           <p:nvPr/>
         </p:nvSpPr>
@@ -3170,7 +3410,7 @@
       </p:sp>
       <p:sp>
         <p:nvSpPr>
-          <p:cNvPr id="65" name="Text 63"/>
+          <p:cNvPr id="77" name="Text 75"/>
           <p:cNvSpPr txBox="1"/>
           <p:nvPr/>
         </p:nvSpPr>
@@ -3209,14 +3449,14 @@
       </p:sp>
       <p:sp>
         <p:nvSpPr>
-          <p:cNvPr id="66" name="Shape 64"/>
+          <p:cNvPr id="78" name="Shape 76"/>
           <p:cNvSpPr/>
           <p:nvPr/>
         </p:nvSpPr>
         <p:spPr>
           <a:xfrm>
             <a:off x="3008376" y="5144262"/>
-            <a:ext cx="1039396" cy="104140"/>
+            <a:ext cx="1289251" cy="104140"/>
           </a:xfrm>
           <a:prstGeom prst="rect">
             <a:avLst/>
@@ -3229,7 +3469,27 @@
       </p:sp>
       <p:sp>
         <p:nvSpPr>
-          <p:cNvPr id="67" name="Text 65"/>
+          <p:cNvPr id="79" name="Shape 77"/>
+          <p:cNvSpPr/>
+          <p:nvPr/>
+        </p:nvSpPr>
+        <p:spPr>
+          <a:xfrm>
+            <a:off x="4189582" y="5113020"/>
+            <a:ext cx="21946" cy="166624"/>
+          </a:xfrm>
+          <a:prstGeom prst="rect">
+            <a:avLst/>
+          </a:prstGeom>
+          <a:solidFill>
+            <a:srgbClr val="0B2C4A"/>
+          </a:solidFill>
+          <a:ln/>
+        </p:spPr>
+      </p:sp>
+      <p:sp>
+        <p:nvSpPr>
+          <p:cNvPr id="80" name="Text 78"/>
           <p:cNvSpPr txBox="1"/>
           <p:nvPr/>
         </p:nvSpPr>
@@ -3268,7 +3528,7 @@
       </p:sp>
       <p:sp>
         <p:nvSpPr>
-          <p:cNvPr id="68" name="Text 66"/>
+          <p:cNvPr id="81" name="Text 79"/>
           <p:cNvSpPr txBox="1"/>
           <p:nvPr/>
         </p:nvSpPr>
@@ -3307,7 +3567,7 @@
       </p:sp>
       <p:sp>
         <p:nvSpPr>
-          <p:cNvPr id="69" name="Text 67"/>
+          <p:cNvPr id="82" name="Text 80"/>
           <p:cNvSpPr txBox="1"/>
           <p:nvPr/>
         </p:nvSpPr>
@@ -3346,14 +3606,14 @@
       </p:sp>
       <p:sp>
         <p:nvSpPr>
-          <p:cNvPr id="70" name="Shape 68"/>
+          <p:cNvPr id="83" name="Shape 81"/>
           <p:cNvSpPr/>
           <p:nvPr/>
         </p:nvSpPr>
         <p:spPr>
           <a:xfrm>
             <a:off x="3008376" y="5352542"/>
-            <a:ext cx="1034412" cy="104140"/>
+            <a:ext cx="1283069" cy="104140"/>
           </a:xfrm>
           <a:prstGeom prst="rect">
             <a:avLst/>
@@ -3366,7 +3626,27 @@
       </p:sp>
       <p:sp>
         <p:nvSpPr>
-          <p:cNvPr id="71" name="Text 69"/>
+          <p:cNvPr id="84" name="Shape 82"/>
+          <p:cNvSpPr/>
+          <p:nvPr/>
+        </p:nvSpPr>
+        <p:spPr>
+          <a:xfrm>
+            <a:off x="4189582" y="5321300"/>
+            <a:ext cx="21946" cy="166624"/>
+          </a:xfrm>
+          <a:prstGeom prst="rect">
+            <a:avLst/>
+          </a:prstGeom>
+          <a:solidFill>
+            <a:srgbClr val="0B2C4A"/>
+          </a:solidFill>
+          <a:ln/>
+        </p:spPr>
+      </p:sp>
+      <p:sp>
+        <p:nvSpPr>
+          <p:cNvPr id="85" name="Text 83"/>
           <p:cNvSpPr txBox="1"/>
           <p:nvPr/>
         </p:nvSpPr>
@@ -3405,7 +3685,7 @@
       </p:sp>
       <p:sp>
         <p:nvSpPr>
-          <p:cNvPr id="72" name="Text 70"/>
+          <p:cNvPr id="86" name="Text 84"/>
           <p:cNvSpPr txBox="1"/>
           <p:nvPr/>
         </p:nvSpPr>
@@ -3444,7 +3724,7 @@
       </p:sp>
       <p:sp>
         <p:nvSpPr>
-          <p:cNvPr id="73" name="Text 71"/>
+          <p:cNvPr id="87" name="Text 85"/>
           <p:cNvSpPr txBox="1"/>
           <p:nvPr/>
         </p:nvSpPr>
@@ -3483,14 +3763,14 @@
       </p:sp>
       <p:sp>
         <p:nvSpPr>
-          <p:cNvPr id="74" name="Shape 72"/>
+          <p:cNvPr id="88" name="Shape 86"/>
           <p:cNvSpPr/>
           <p:nvPr/>
         </p:nvSpPr>
         <p:spPr>
           <a:xfrm>
             <a:off x="3008376" y="5560822"/>
-            <a:ext cx="1020490" cy="104140"/>
+            <a:ext cx="1265801" cy="104140"/>
           </a:xfrm>
           <a:prstGeom prst="rect">
             <a:avLst/>
@@ -3503,7 +3783,27 @@
       </p:sp>
       <p:sp>
         <p:nvSpPr>
-          <p:cNvPr id="75" name="Text 73"/>
+          <p:cNvPr id="89" name="Shape 87"/>
+          <p:cNvSpPr/>
+          <p:nvPr/>
+        </p:nvSpPr>
+        <p:spPr>
+          <a:xfrm>
+            <a:off x="4189582" y="5529580"/>
+            <a:ext cx="21946" cy="166624"/>
+          </a:xfrm>
+          <a:prstGeom prst="rect">
+            <a:avLst/>
+          </a:prstGeom>
+          <a:solidFill>
+            <a:srgbClr val="0B2C4A"/>
+          </a:solidFill>
+          <a:ln/>
+        </p:spPr>
+      </p:sp>
+      <p:sp>
+        <p:nvSpPr>
+          <p:cNvPr id="90" name="Text 88"/>
           <p:cNvSpPr txBox="1"/>
           <p:nvPr/>
         </p:nvSpPr>
@@ -3542,7 +3842,7 @@
       </p:sp>
       <p:sp>
         <p:nvSpPr>
-          <p:cNvPr id="76" name="Text 74"/>
+          <p:cNvPr id="91" name="Text 89"/>
           <p:cNvSpPr txBox="1"/>
           <p:nvPr/>
         </p:nvSpPr>
@@ -3581,7 +3881,7 @@
       </p:sp>
       <p:sp>
         <p:nvSpPr>
-          <p:cNvPr id="77" name="Text 75"/>
+          <p:cNvPr id="92" name="Text 90"/>
           <p:cNvSpPr txBox="1"/>
           <p:nvPr/>
         </p:nvSpPr>
@@ -3620,14 +3920,14 @@
       </p:sp>
       <p:sp>
         <p:nvSpPr>
-          <p:cNvPr id="78" name="Shape 76"/>
+          <p:cNvPr id="93" name="Shape 91"/>
           <p:cNvSpPr/>
           <p:nvPr/>
         </p:nvSpPr>
         <p:spPr>
           <a:xfrm>
             <a:off x="3008376" y="5769102"/>
-            <a:ext cx="1013557" cy="104140"/>
+            <a:ext cx="1257200" cy="104140"/>
           </a:xfrm>
           <a:prstGeom prst="rect">
             <a:avLst/>
@@ -3640,7 +3940,27 @@
       </p:sp>
       <p:sp>
         <p:nvSpPr>
-          <p:cNvPr id="79" name="Text 77"/>
+          <p:cNvPr id="94" name="Shape 92"/>
+          <p:cNvSpPr/>
+          <p:nvPr/>
+        </p:nvSpPr>
+        <p:spPr>
+          <a:xfrm>
+            <a:off x="4189582" y="5737860"/>
+            <a:ext cx="21946" cy="166624"/>
+          </a:xfrm>
+          <a:prstGeom prst="rect">
+            <a:avLst/>
+          </a:prstGeom>
+          <a:solidFill>
+            <a:srgbClr val="0B2C4A"/>
+          </a:solidFill>
+          <a:ln/>
+        </p:spPr>
+      </p:sp>
+      <p:sp>
+        <p:nvSpPr>
+          <p:cNvPr id="95" name="Text 93"/>
           <p:cNvSpPr txBox="1"/>
           <p:nvPr/>
         </p:nvSpPr>
@@ -3679,7 +3999,7 @@
       </p:sp>
       <p:sp>
         <p:nvSpPr>
-          <p:cNvPr id="80" name="Text 78"/>
+          <p:cNvPr id="96" name="Text 94"/>
           <p:cNvSpPr txBox="1"/>
           <p:nvPr/>
         </p:nvSpPr>
@@ -3718,7 +4038,7 @@
       </p:sp>
       <p:sp>
         <p:nvSpPr>
-          <p:cNvPr id="81" name="Text 79"/>
+          <p:cNvPr id="97" name="Text 95"/>
           <p:cNvSpPr txBox="1"/>
           <p:nvPr/>
         </p:nvSpPr>
@@ -3757,14 +4077,14 @@
       </p:sp>
       <p:sp>
         <p:nvSpPr>
-          <p:cNvPr id="82" name="Shape 80"/>
+          <p:cNvPr id="98" name="Shape 96"/>
           <p:cNvSpPr/>
           <p:nvPr/>
         </p:nvSpPr>
         <p:spPr>
           <a:xfrm>
             <a:off x="8558784" y="2228342"/>
-            <a:ext cx="1012325" cy="104140"/>
+            <a:ext cx="1255672" cy="104140"/>
           </a:xfrm>
           <a:prstGeom prst="rect">
             <a:avLst/>
@@ -3777,7 +4097,27 @@
       </p:sp>
       <p:sp>
         <p:nvSpPr>
-          <p:cNvPr id="83" name="Text 81"/>
+          <p:cNvPr id="99" name="Shape 97"/>
+          <p:cNvSpPr/>
+          <p:nvPr/>
+        </p:nvSpPr>
+        <p:spPr>
+          <a:xfrm>
+            <a:off x="9739990" y="2197100"/>
+            <a:ext cx="21946" cy="166624"/>
+          </a:xfrm>
+          <a:prstGeom prst="rect">
+            <a:avLst/>
+          </a:prstGeom>
+          <a:solidFill>
+            <a:srgbClr val="0B2C4A"/>
+          </a:solidFill>
+          <a:ln/>
+        </p:spPr>
+      </p:sp>
+      <p:sp>
+        <p:nvSpPr>
+          <p:cNvPr id="100" name="Text 98"/>
           <p:cNvSpPr txBox="1"/>
           <p:nvPr/>
         </p:nvSpPr>
@@ -3816,7 +4156,7 @@
       </p:sp>
       <p:sp>
         <p:nvSpPr>
-          <p:cNvPr id="84" name="Text 82"/>
+          <p:cNvPr id="101" name="Text 99"/>
           <p:cNvSpPr txBox="1"/>
           <p:nvPr/>
         </p:nvSpPr>
@@ -3855,7 +4195,7 @@
       </p:sp>
       <p:sp>
         <p:nvSpPr>
-          <p:cNvPr id="85" name="Text 83"/>
+          <p:cNvPr id="102" name="Text 100"/>
           <p:cNvSpPr txBox="1"/>
           <p:nvPr/>
         </p:nvSpPr>
@@ -3894,14 +4234,14 @@
       </p:sp>
       <p:sp>
         <p:nvSpPr>
-          <p:cNvPr id="86" name="Shape 84"/>
+          <p:cNvPr id="103" name="Shape 101"/>
           <p:cNvSpPr/>
           <p:nvPr/>
         </p:nvSpPr>
         <p:spPr>
           <a:xfrm>
             <a:off x="8558784" y="2436622"/>
-            <a:ext cx="999384" cy="104140"/>
+            <a:ext cx="1239620" cy="104140"/>
           </a:xfrm>
           <a:prstGeom prst="rect">
             <a:avLst/>
@@ -3914,7 +4254,27 @@
       </p:sp>
       <p:sp>
         <p:nvSpPr>
-          <p:cNvPr id="87" name="Text 85"/>
+          <p:cNvPr id="104" name="Shape 102"/>
+          <p:cNvSpPr/>
+          <p:nvPr/>
+        </p:nvSpPr>
+        <p:spPr>
+          <a:xfrm>
+            <a:off x="9739990" y="2405380"/>
+            <a:ext cx="21946" cy="166624"/>
+          </a:xfrm>
+          <a:prstGeom prst="rect">
+            <a:avLst/>
+          </a:prstGeom>
+          <a:solidFill>
+            <a:srgbClr val="0B2C4A"/>
+          </a:solidFill>
+          <a:ln/>
+        </p:spPr>
+      </p:sp>
+      <p:sp>
+        <p:nvSpPr>
+          <p:cNvPr id="105" name="Text 103"/>
           <p:cNvSpPr txBox="1"/>
           <p:nvPr/>
         </p:nvSpPr>
@@ -3953,7 +4313,7 @@
       </p:sp>
       <p:sp>
         <p:nvSpPr>
-          <p:cNvPr id="88" name="Text 86"/>
+          <p:cNvPr id="106" name="Text 104"/>
           <p:cNvSpPr txBox="1"/>
           <p:nvPr/>
         </p:nvSpPr>
@@ -3992,7 +4352,7 @@
       </p:sp>
       <p:sp>
         <p:nvSpPr>
-          <p:cNvPr id="89" name="Text 87"/>
+          <p:cNvPr id="107" name="Text 105"/>
           <p:cNvSpPr txBox="1"/>
           <p:nvPr/>
         </p:nvSpPr>
@@ -4031,14 +4391,14 @@
       </p:sp>
       <p:sp>
         <p:nvSpPr>
-          <p:cNvPr id="90" name="Shape 88"/>
+          <p:cNvPr id="108" name="Shape 106"/>
           <p:cNvSpPr/>
           <p:nvPr/>
         </p:nvSpPr>
         <p:spPr>
           <a:xfrm>
             <a:off x="8558784" y="2644902"/>
-            <a:ext cx="992055" cy="104140"/>
+            <a:ext cx="1230530" cy="104140"/>
           </a:xfrm>
           <a:prstGeom prst="rect">
             <a:avLst/>
@@ -4051,7 +4411,27 @@
       </p:sp>
       <p:sp>
         <p:nvSpPr>
-          <p:cNvPr id="91" name="Text 89"/>
+          <p:cNvPr id="109" name="Shape 107"/>
+          <p:cNvSpPr/>
+          <p:nvPr/>
+        </p:nvSpPr>
+        <p:spPr>
+          <a:xfrm>
+            <a:off x="9739990" y="2613660"/>
+            <a:ext cx="21946" cy="166624"/>
+          </a:xfrm>
+          <a:prstGeom prst="rect">
+            <a:avLst/>
+          </a:prstGeom>
+          <a:solidFill>
+            <a:srgbClr val="0B2C4A"/>
+          </a:solidFill>
+          <a:ln/>
+        </p:spPr>
+      </p:sp>
+      <p:sp>
+        <p:nvSpPr>
+          <p:cNvPr id="110" name="Text 108"/>
           <p:cNvSpPr txBox="1"/>
           <p:nvPr/>
         </p:nvSpPr>
@@ -4090,7 +4470,7 @@
       </p:sp>
       <p:sp>
         <p:nvSpPr>
-          <p:cNvPr id="92" name="Text 90"/>
+          <p:cNvPr id="111" name="Text 109"/>
           <p:cNvSpPr txBox="1"/>
           <p:nvPr/>
         </p:nvSpPr>
@@ -4129,7 +4509,7 @@
       </p:sp>
       <p:sp>
         <p:nvSpPr>
-          <p:cNvPr id="93" name="Text 91"/>
+          <p:cNvPr id="112" name="Text 110"/>
           <p:cNvSpPr txBox="1"/>
           <p:nvPr/>
         </p:nvSpPr>
@@ -4168,14 +4548,14 @@
       </p:sp>
       <p:sp>
         <p:nvSpPr>
-          <p:cNvPr id="94" name="Shape 92"/>
+          <p:cNvPr id="113" name="Shape 111"/>
           <p:cNvSpPr/>
           <p:nvPr/>
         </p:nvSpPr>
         <p:spPr>
           <a:xfrm>
             <a:off x="8558784" y="2853182"/>
-            <a:ext cx="981413" cy="104140"/>
+            <a:ext cx="1217330" cy="104140"/>
           </a:xfrm>
           <a:prstGeom prst="rect">
             <a:avLst/>
@@ -4188,7 +4568,27 @@
       </p:sp>
       <p:sp>
         <p:nvSpPr>
-          <p:cNvPr id="95" name="Text 93"/>
+          <p:cNvPr id="114" name="Shape 112"/>
+          <p:cNvSpPr/>
+          <p:nvPr/>
+        </p:nvSpPr>
+        <p:spPr>
+          <a:xfrm>
+            <a:off x="9739990" y="2821940"/>
+            <a:ext cx="21946" cy="166624"/>
+          </a:xfrm>
+          <a:prstGeom prst="rect">
+            <a:avLst/>
+          </a:prstGeom>
+          <a:solidFill>
+            <a:srgbClr val="0B2C4A"/>
+          </a:solidFill>
+          <a:ln/>
+        </p:spPr>
+      </p:sp>
+      <p:sp>
+        <p:nvSpPr>
+          <p:cNvPr id="115" name="Text 113"/>
           <p:cNvSpPr txBox="1"/>
           <p:nvPr/>
         </p:nvSpPr>
@@ -4227,7 +4627,7 @@
       </p:sp>
       <p:sp>
         <p:nvSpPr>
-          <p:cNvPr id="96" name="Text 94"/>
+          <p:cNvPr id="116" name="Text 114"/>
           <p:cNvSpPr txBox="1"/>
           <p:nvPr/>
         </p:nvSpPr>
@@ -4266,7 +4666,7 @@
       </p:sp>
       <p:sp>
         <p:nvSpPr>
-          <p:cNvPr id="97" name="Text 95"/>
+          <p:cNvPr id="117" name="Text 115"/>
           <p:cNvSpPr txBox="1"/>
           <p:nvPr/>
         </p:nvSpPr>
@@ -4305,14 +4705,14 @@
       </p:sp>
       <p:sp>
         <p:nvSpPr>
-          <p:cNvPr id="98" name="Shape 96"/>
+          <p:cNvPr id="118" name="Shape 116"/>
           <p:cNvSpPr/>
           <p:nvPr/>
         </p:nvSpPr>
         <p:spPr>
           <a:xfrm>
             <a:off x="8558784" y="3061462"/>
-            <a:ext cx="973651" cy="104140"/>
+            <a:ext cx="1207702" cy="104140"/>
           </a:xfrm>
           <a:prstGeom prst="rect">
             <a:avLst/>
@@ -4325,7 +4725,27 @@
       </p:sp>
       <p:sp>
         <p:nvSpPr>
-          <p:cNvPr id="99" name="Text 97"/>
+          <p:cNvPr id="119" name="Shape 117"/>
+          <p:cNvSpPr/>
+          <p:nvPr/>
+        </p:nvSpPr>
+        <p:spPr>
+          <a:xfrm>
+            <a:off x="9739990" y="3030220"/>
+            <a:ext cx="21946" cy="166624"/>
+          </a:xfrm>
+          <a:prstGeom prst="rect">
+            <a:avLst/>
+          </a:prstGeom>
+          <a:solidFill>
+            <a:srgbClr val="0B2C4A"/>
+          </a:solidFill>
+          <a:ln/>
+        </p:spPr>
+      </p:sp>
+      <p:sp>
+        <p:nvSpPr>
+          <p:cNvPr id="120" name="Text 118"/>
           <p:cNvSpPr txBox="1"/>
           <p:nvPr/>
         </p:nvSpPr>
@@ -4364,7 +4784,7 @@
       </p:sp>
       <p:sp>
         <p:nvSpPr>
-          <p:cNvPr id="100" name="Text 98"/>
+          <p:cNvPr id="121" name="Text 119"/>
           <p:cNvSpPr txBox="1"/>
           <p:nvPr/>
         </p:nvSpPr>
@@ -4403,7 +4823,7 @@
       </p:sp>
       <p:sp>
         <p:nvSpPr>
-          <p:cNvPr id="101" name="Text 99"/>
+          <p:cNvPr id="122" name="Text 120"/>
           <p:cNvSpPr txBox="1"/>
           <p:nvPr/>
         </p:nvSpPr>
@@ -4442,14 +4862,14 @@
       </p:sp>
       <p:sp>
         <p:nvSpPr>
-          <p:cNvPr id="102" name="Shape 100"/>
+          <p:cNvPr id="123" name="Shape 121"/>
           <p:cNvSpPr/>
           <p:nvPr/>
         </p:nvSpPr>
         <p:spPr>
           <a:xfrm>
             <a:off x="8558784" y="3269742"/>
-            <a:ext cx="947879" cy="104140"/>
+            <a:ext cx="1175735" cy="104140"/>
           </a:xfrm>
           <a:prstGeom prst="rect">
             <a:avLst/>
@@ -4462,7 +4882,27 @@
       </p:sp>
       <p:sp>
         <p:nvSpPr>
-          <p:cNvPr id="103" name="Text 101"/>
+          <p:cNvPr id="124" name="Shape 122"/>
+          <p:cNvSpPr/>
+          <p:nvPr/>
+        </p:nvSpPr>
+        <p:spPr>
+          <a:xfrm>
+            <a:off x="9739990" y="3238500"/>
+            <a:ext cx="21946" cy="166624"/>
+          </a:xfrm>
+          <a:prstGeom prst="rect">
+            <a:avLst/>
+          </a:prstGeom>
+          <a:solidFill>
+            <a:srgbClr val="0B2C4A"/>
+          </a:solidFill>
+          <a:ln/>
+        </p:spPr>
+      </p:sp>
+      <p:sp>
+        <p:nvSpPr>
+          <p:cNvPr id="125" name="Text 123"/>
           <p:cNvSpPr txBox="1"/>
           <p:nvPr/>
         </p:nvSpPr>
@@ -4501,7 +4941,7 @@
       </p:sp>
       <p:sp>
         <p:nvSpPr>
-          <p:cNvPr id="104" name="Text 102"/>
+          <p:cNvPr id="126" name="Text 124"/>
           <p:cNvSpPr txBox="1"/>
           <p:nvPr/>
         </p:nvSpPr>
@@ -4540,7 +4980,7 @@
       </p:sp>
       <p:sp>
         <p:nvSpPr>
-          <p:cNvPr id="105" name="Text 103"/>
+          <p:cNvPr id="127" name="Text 125"/>
           <p:cNvSpPr txBox="1"/>
           <p:nvPr/>
         </p:nvSpPr>
@@ -4579,14 +5019,14 @@
       </p:sp>
       <p:sp>
         <p:nvSpPr>
-          <p:cNvPr id="106" name="Shape 104"/>
+          <p:cNvPr id="128" name="Shape 126"/>
           <p:cNvSpPr/>
           <p:nvPr/>
         </p:nvSpPr>
         <p:spPr>
           <a:xfrm>
             <a:off x="8558784" y="3478022"/>
-            <a:ext cx="941534" cy="104140"/>
+            <a:ext cx="1167864" cy="104140"/>
           </a:xfrm>
           <a:prstGeom prst="rect">
             <a:avLst/>
@@ -4599,7 +5039,27 @@
       </p:sp>
       <p:sp>
         <p:nvSpPr>
-          <p:cNvPr id="107" name="Text 105"/>
+          <p:cNvPr id="129" name="Shape 127"/>
+          <p:cNvSpPr/>
+          <p:nvPr/>
+        </p:nvSpPr>
+        <p:spPr>
+          <a:xfrm>
+            <a:off x="9739990" y="3446780"/>
+            <a:ext cx="21946" cy="166624"/>
+          </a:xfrm>
+          <a:prstGeom prst="rect">
+            <a:avLst/>
+          </a:prstGeom>
+          <a:solidFill>
+            <a:srgbClr val="0B2C4A"/>
+          </a:solidFill>
+          <a:ln/>
+        </p:spPr>
+      </p:sp>
+      <p:sp>
+        <p:nvSpPr>
+          <p:cNvPr id="130" name="Text 128"/>
           <p:cNvSpPr txBox="1"/>
           <p:nvPr/>
         </p:nvSpPr>
@@ -4638,7 +5098,7 @@
       </p:sp>
       <p:sp>
         <p:nvSpPr>
-          <p:cNvPr id="108" name="Text 106"/>
+          <p:cNvPr id="131" name="Text 129"/>
           <p:cNvSpPr txBox="1"/>
           <p:nvPr/>
         </p:nvSpPr>
@@ -4677,7 +5137,7 @@
       </p:sp>
       <p:sp>
         <p:nvSpPr>
-          <p:cNvPr id="109" name="Text 107"/>
+          <p:cNvPr id="132" name="Text 130"/>
           <p:cNvSpPr txBox="1"/>
           <p:nvPr/>
         </p:nvSpPr>
@@ -4716,14 +5176,14 @@
       </p:sp>
       <p:sp>
         <p:nvSpPr>
-          <p:cNvPr id="110" name="Shape 108"/>
+          <p:cNvPr id="133" name="Shape 131"/>
           <p:cNvSpPr/>
           <p:nvPr/>
         </p:nvSpPr>
         <p:spPr>
           <a:xfrm>
             <a:off x="8558784" y="3686302"/>
-            <a:ext cx="917807" cy="104140"/>
+            <a:ext cx="1138434" cy="104140"/>
           </a:xfrm>
           <a:prstGeom prst="rect">
             <a:avLst/>
@@ -4736,7 +5196,27 @@
       </p:sp>
       <p:sp>
         <p:nvSpPr>
-          <p:cNvPr id="111" name="Text 109"/>
+          <p:cNvPr id="134" name="Shape 132"/>
+          <p:cNvSpPr/>
+          <p:nvPr/>
+        </p:nvSpPr>
+        <p:spPr>
+          <a:xfrm>
+            <a:off x="9739990" y="3655060"/>
+            <a:ext cx="21946" cy="166624"/>
+          </a:xfrm>
+          <a:prstGeom prst="rect">
+            <a:avLst/>
+          </a:prstGeom>
+          <a:solidFill>
+            <a:srgbClr val="0B2C4A"/>
+          </a:solidFill>
+          <a:ln/>
+        </p:spPr>
+      </p:sp>
+      <p:sp>
+        <p:nvSpPr>
+          <p:cNvPr id="135" name="Text 133"/>
           <p:cNvSpPr txBox="1"/>
           <p:nvPr/>
         </p:nvSpPr>
@@ -4775,7 +5255,7 @@
       </p:sp>
       <p:sp>
         <p:nvSpPr>
-          <p:cNvPr id="112" name="Text 110"/>
+          <p:cNvPr id="136" name="Text 134"/>
           <p:cNvSpPr txBox="1"/>
           <p:nvPr/>
         </p:nvSpPr>
@@ -4814,7 +5294,7 @@
       </p:sp>
       <p:sp>
         <p:nvSpPr>
-          <p:cNvPr id="113" name="Text 111"/>
+          <p:cNvPr id="137" name="Text 135"/>
           <p:cNvSpPr txBox="1"/>
           <p:nvPr/>
         </p:nvSpPr>
@@ -4853,14 +5333,14 @@
       </p:sp>
       <p:sp>
         <p:nvSpPr>
-          <p:cNvPr id="114" name="Shape 112"/>
+          <p:cNvPr id="138" name="Shape 136"/>
           <p:cNvSpPr/>
           <p:nvPr/>
         </p:nvSpPr>
         <p:spPr>
           <a:xfrm>
             <a:off x="8558784" y="3894582"/>
-            <a:ext cx="913971" cy="104140"/>
+            <a:ext cx="1133676" cy="104140"/>
           </a:xfrm>
           <a:prstGeom prst="rect">
             <a:avLst/>
@@ -4873,7 +5353,27 @@
       </p:sp>
       <p:sp>
         <p:nvSpPr>
-          <p:cNvPr id="115" name="Text 113"/>
+          <p:cNvPr id="139" name="Shape 137"/>
+          <p:cNvSpPr/>
+          <p:nvPr/>
+        </p:nvSpPr>
+        <p:spPr>
+          <a:xfrm>
+            <a:off x="9739990" y="3863340"/>
+            <a:ext cx="21946" cy="166624"/>
+          </a:xfrm>
+          <a:prstGeom prst="rect">
+            <a:avLst/>
+          </a:prstGeom>
+          <a:solidFill>
+            <a:srgbClr val="0B2C4A"/>
+          </a:solidFill>
+          <a:ln/>
+        </p:spPr>
+      </p:sp>
+      <p:sp>
+        <p:nvSpPr>
+          <p:cNvPr id="140" name="Text 138"/>
           <p:cNvSpPr txBox="1"/>
           <p:nvPr/>
         </p:nvSpPr>
@@ -4912,7 +5412,7 @@
       </p:sp>
       <p:sp>
         <p:nvSpPr>
-          <p:cNvPr id="116" name="Text 114"/>
+          <p:cNvPr id="141" name="Text 139"/>
           <p:cNvSpPr txBox="1"/>
           <p:nvPr/>
         </p:nvSpPr>
@@ -4951,7 +5451,7 @@
       </p:sp>
       <p:sp>
         <p:nvSpPr>
-          <p:cNvPr id="117" name="Text 115"/>
+          <p:cNvPr id="142" name="Text 140"/>
           <p:cNvSpPr txBox="1"/>
           <p:nvPr/>
         </p:nvSpPr>
@@ -4990,14 +5490,14 @@
       </p:sp>
       <p:sp>
         <p:nvSpPr>
-          <p:cNvPr id="118" name="Shape 116"/>
+          <p:cNvPr id="143" name="Shape 141"/>
           <p:cNvSpPr/>
           <p:nvPr/>
         </p:nvSpPr>
         <p:spPr>
           <a:xfrm>
             <a:off x="8558784" y="4102862"/>
-            <a:ext cx="908662" cy="104140"/>
+            <a:ext cx="1127091" cy="104140"/>
           </a:xfrm>
           <a:prstGeom prst="rect">
             <a:avLst/>
@@ -5010,7 +5510,27 @@
       </p:sp>
       <p:sp>
         <p:nvSpPr>
-          <p:cNvPr id="119" name="Text 117"/>
+          <p:cNvPr id="144" name="Shape 142"/>
+          <p:cNvSpPr/>
+          <p:nvPr/>
+        </p:nvSpPr>
+        <p:spPr>
+          <a:xfrm>
+            <a:off x="9739990" y="4071620"/>
+            <a:ext cx="21946" cy="166624"/>
+          </a:xfrm>
+          <a:prstGeom prst="rect">
+            <a:avLst/>
+          </a:prstGeom>
+          <a:solidFill>
+            <a:srgbClr val="0B2C4A"/>
+          </a:solidFill>
+          <a:ln/>
+        </p:spPr>
+      </p:sp>
+      <p:sp>
+        <p:nvSpPr>
+          <p:cNvPr id="145" name="Text 143"/>
           <p:cNvSpPr txBox="1"/>
           <p:nvPr/>
         </p:nvSpPr>
@@ -5049,7 +5569,7 @@
       </p:sp>
       <p:sp>
         <p:nvSpPr>
-          <p:cNvPr id="120" name="Text 118"/>
+          <p:cNvPr id="146" name="Text 144"/>
           <p:cNvSpPr txBox="1"/>
           <p:nvPr/>
         </p:nvSpPr>
@@ -5088,7 +5608,7 @@
       </p:sp>
       <p:sp>
         <p:nvSpPr>
-          <p:cNvPr id="121" name="Text 119"/>
+          <p:cNvPr id="147" name="Text 145"/>
           <p:cNvSpPr txBox="1"/>
           <p:nvPr/>
         </p:nvSpPr>
@@ -5127,14 +5647,14 @@
       </p:sp>
       <p:sp>
         <p:nvSpPr>
-          <p:cNvPr id="122" name="Shape 120"/>
+          <p:cNvPr id="148" name="Shape 146"/>
           <p:cNvSpPr/>
           <p:nvPr/>
         </p:nvSpPr>
         <p:spPr>
           <a:xfrm>
             <a:off x="8558784" y="4311142"/>
-            <a:ext cx="907021" cy="104140"/>
+            <a:ext cx="1125055" cy="104140"/>
           </a:xfrm>
           <a:prstGeom prst="rect">
             <a:avLst/>
@@ -5147,7 +5667,27 @@
       </p:sp>
       <p:sp>
         <p:nvSpPr>
-          <p:cNvPr id="123" name="Text 121"/>
+          <p:cNvPr id="149" name="Shape 147"/>
+          <p:cNvSpPr/>
+          <p:nvPr/>
+        </p:nvSpPr>
+        <p:spPr>
+          <a:xfrm>
+            <a:off x="9739990" y="4279900"/>
+            <a:ext cx="21946" cy="166624"/>
+          </a:xfrm>
+          <a:prstGeom prst="rect">
+            <a:avLst/>
+          </a:prstGeom>
+          <a:solidFill>
+            <a:srgbClr val="0B2C4A"/>
+          </a:solidFill>
+          <a:ln/>
+        </p:spPr>
+      </p:sp>
+      <p:sp>
+        <p:nvSpPr>
+          <p:cNvPr id="150" name="Text 148"/>
           <p:cNvSpPr txBox="1"/>
           <p:nvPr/>
         </p:nvSpPr>
@@ -5186,7 +5726,7 @@
       </p:sp>
       <p:sp>
         <p:nvSpPr>
-          <p:cNvPr id="124" name="Text 122"/>
+          <p:cNvPr id="151" name="Text 149"/>
           <p:cNvSpPr txBox="1"/>
           <p:nvPr/>
         </p:nvSpPr>
@@ -5225,7 +5765,7 @@
       </p:sp>
       <p:sp>
         <p:nvSpPr>
-          <p:cNvPr id="125" name="Text 123"/>
+          <p:cNvPr id="152" name="Text 150"/>
           <p:cNvSpPr txBox="1"/>
           <p:nvPr/>
         </p:nvSpPr>
@@ -5264,14 +5804,14 @@
       </p:sp>
       <p:sp>
         <p:nvSpPr>
-          <p:cNvPr id="126" name="Shape 124"/>
+          <p:cNvPr id="153" name="Shape 151"/>
           <p:cNvSpPr/>
           <p:nvPr/>
         </p:nvSpPr>
         <p:spPr>
           <a:xfrm>
             <a:off x="8558784" y="4519422"/>
-            <a:ext cx="896260" cy="104140"/>
+            <a:ext cx="1111707" cy="104140"/>
           </a:xfrm>
           <a:prstGeom prst="rect">
             <a:avLst/>
@@ -5284,7 +5824,27 @@
       </p:sp>
       <p:sp>
         <p:nvSpPr>
-          <p:cNvPr id="127" name="Text 125"/>
+          <p:cNvPr id="154" name="Shape 152"/>
+          <p:cNvSpPr/>
+          <p:nvPr/>
+        </p:nvSpPr>
+        <p:spPr>
+          <a:xfrm>
+            <a:off x="9739990" y="4488180"/>
+            <a:ext cx="21946" cy="166624"/>
+          </a:xfrm>
+          <a:prstGeom prst="rect">
+            <a:avLst/>
+          </a:prstGeom>
+          <a:solidFill>
+            <a:srgbClr val="0B2C4A"/>
+          </a:solidFill>
+          <a:ln/>
+        </p:spPr>
+      </p:sp>
+      <p:sp>
+        <p:nvSpPr>
+          <p:cNvPr id="155" name="Text 153"/>
           <p:cNvSpPr txBox="1"/>
           <p:nvPr/>
         </p:nvSpPr>
@@ -5323,7 +5883,7 @@
       </p:sp>
       <p:sp>
         <p:nvSpPr>
-          <p:cNvPr id="128" name="Text 126"/>
+          <p:cNvPr id="156" name="Text 154"/>
           <p:cNvSpPr txBox="1"/>
           <p:nvPr/>
         </p:nvSpPr>
@@ -5362,7 +5922,7 @@
       </p:sp>
       <p:sp>
         <p:nvSpPr>
-          <p:cNvPr id="129" name="Text 127"/>
+          <p:cNvPr id="157" name="Text 155"/>
           <p:cNvSpPr txBox="1"/>
           <p:nvPr/>
         </p:nvSpPr>
@@ -5401,14 +5961,14 @@
       </p:sp>
       <p:sp>
         <p:nvSpPr>
-          <p:cNvPr id="130" name="Shape 128"/>
+          <p:cNvPr id="158" name="Shape 156"/>
           <p:cNvSpPr/>
           <p:nvPr/>
         </p:nvSpPr>
         <p:spPr>
           <a:xfrm>
             <a:off x="8558784" y="4727702"/>
-            <a:ext cx="883720" cy="104140"/>
+            <a:ext cx="1096152" cy="104140"/>
           </a:xfrm>
           <a:prstGeom prst="rect">
             <a:avLst/>
@@ -5421,7 +5981,27 @@
       </p:sp>
       <p:sp>
         <p:nvSpPr>
-          <p:cNvPr id="131" name="Text 129"/>
+          <p:cNvPr id="159" name="Shape 157"/>
+          <p:cNvSpPr/>
+          <p:nvPr/>
+        </p:nvSpPr>
+        <p:spPr>
+          <a:xfrm>
+            <a:off x="9739990" y="4696460"/>
+            <a:ext cx="21946" cy="166624"/>
+          </a:xfrm>
+          <a:prstGeom prst="rect">
+            <a:avLst/>
+          </a:prstGeom>
+          <a:solidFill>
+            <a:srgbClr val="0B2C4A"/>
+          </a:solidFill>
+          <a:ln/>
+        </p:spPr>
+      </p:sp>
+      <p:sp>
+        <p:nvSpPr>
+          <p:cNvPr id="160" name="Text 158"/>
           <p:cNvSpPr txBox="1"/>
           <p:nvPr/>
         </p:nvSpPr>
@@ -5460,7 +6040,7 @@
       </p:sp>
       <p:sp>
         <p:nvSpPr>
-          <p:cNvPr id="132" name="Text 130"/>
+          <p:cNvPr id="161" name="Text 159"/>
           <p:cNvSpPr txBox="1"/>
           <p:nvPr/>
         </p:nvSpPr>
@@ -5499,7 +6079,7 @@
       </p:sp>
       <p:sp>
         <p:nvSpPr>
-          <p:cNvPr id="133" name="Text 131"/>
+          <p:cNvPr id="162" name="Text 160"/>
           <p:cNvSpPr txBox="1"/>
           <p:nvPr/>
         </p:nvSpPr>
@@ -5538,14 +6118,14 @@
       </p:sp>
       <p:sp>
         <p:nvSpPr>
-          <p:cNvPr id="134" name="Shape 132"/>
+          <p:cNvPr id="163" name="Shape 161"/>
           <p:cNvSpPr/>
           <p:nvPr/>
         </p:nvSpPr>
         <p:spPr>
           <a:xfrm>
             <a:off x="8558784" y="4935982"/>
-            <a:ext cx="879615" cy="104140"/>
+            <a:ext cx="1091062" cy="104140"/>
           </a:xfrm>
           <a:prstGeom prst="rect">
             <a:avLst/>
@@ -5558,7 +6138,27 @@
       </p:sp>
       <p:sp>
         <p:nvSpPr>
-          <p:cNvPr id="135" name="Text 133"/>
+          <p:cNvPr id="164" name="Shape 162"/>
+          <p:cNvSpPr/>
+          <p:nvPr/>
+        </p:nvSpPr>
+        <p:spPr>
+          <a:xfrm>
+            <a:off x="9739990" y="4904740"/>
+            <a:ext cx="21946" cy="166624"/>
+          </a:xfrm>
+          <a:prstGeom prst="rect">
+            <a:avLst/>
+          </a:prstGeom>
+          <a:solidFill>
+            <a:srgbClr val="0B2C4A"/>
+          </a:solidFill>
+          <a:ln/>
+        </p:spPr>
+      </p:sp>
+      <p:sp>
+        <p:nvSpPr>
+          <p:cNvPr id="165" name="Text 163"/>
           <p:cNvSpPr txBox="1"/>
           <p:nvPr/>
         </p:nvSpPr>
@@ -5597,7 +6197,7 @@
       </p:sp>
       <p:sp>
         <p:nvSpPr>
-          <p:cNvPr id="136" name="Text 134"/>
+          <p:cNvPr id="166" name="Text 164"/>
           <p:cNvSpPr txBox="1"/>
           <p:nvPr/>
         </p:nvSpPr>
@@ -5636,7 +6236,7 @@
       </p:sp>
       <p:sp>
         <p:nvSpPr>
-          <p:cNvPr id="137" name="Text 135"/>
+          <p:cNvPr id="167" name="Text 165"/>
           <p:cNvSpPr txBox="1"/>
           <p:nvPr/>
         </p:nvSpPr>
@@ -5675,14 +6275,14 @@
       </p:sp>
       <p:sp>
         <p:nvSpPr>
-          <p:cNvPr id="138" name="Shape 136"/>
+          <p:cNvPr id="168" name="Shape 166"/>
           <p:cNvSpPr/>
           <p:nvPr/>
         </p:nvSpPr>
         <p:spPr>
           <a:xfrm>
             <a:off x="8558784" y="5144262"/>
-            <a:ext cx="858476" cy="104140"/>
+            <a:ext cx="1064841" cy="104140"/>
           </a:xfrm>
           <a:prstGeom prst="rect">
             <a:avLst/>
@@ -5695,7 +6295,27 @@
       </p:sp>
       <p:sp>
         <p:nvSpPr>
-          <p:cNvPr id="139" name="Text 137"/>
+          <p:cNvPr id="169" name="Shape 167"/>
+          <p:cNvSpPr/>
+          <p:nvPr/>
+        </p:nvSpPr>
+        <p:spPr>
+          <a:xfrm>
+            <a:off x="9739990" y="5113020"/>
+            <a:ext cx="21946" cy="166624"/>
+          </a:xfrm>
+          <a:prstGeom prst="rect">
+            <a:avLst/>
+          </a:prstGeom>
+          <a:solidFill>
+            <a:srgbClr val="0B2C4A"/>
+          </a:solidFill>
+          <a:ln/>
+        </p:spPr>
+      </p:sp>
+      <p:sp>
+        <p:nvSpPr>
+          <p:cNvPr id="170" name="Text 168"/>
           <p:cNvSpPr txBox="1"/>
           <p:nvPr/>
         </p:nvSpPr>
@@ -5734,7 +6354,7 @@
       </p:sp>
       <p:sp>
         <p:nvSpPr>
-          <p:cNvPr id="140" name="Text 138"/>
+          <p:cNvPr id="171" name="Text 169"/>
           <p:cNvSpPr txBox="1"/>
           <p:nvPr/>
         </p:nvSpPr>
@@ -5773,7 +6393,7 @@
       </p:sp>
       <p:sp>
         <p:nvSpPr>
-          <p:cNvPr id="141" name="Text 139"/>
+          <p:cNvPr id="172" name="Text 170"/>
           <p:cNvSpPr txBox="1"/>
           <p:nvPr/>
         </p:nvSpPr>
@@ -5812,14 +6432,14 @@
       </p:sp>
       <p:sp>
         <p:nvSpPr>
-          <p:cNvPr id="142" name="Shape 140"/>
+          <p:cNvPr id="173" name="Shape 171"/>
           <p:cNvSpPr/>
           <p:nvPr/>
         </p:nvSpPr>
         <p:spPr>
           <a:xfrm>
             <a:off x="8558784" y="5352542"/>
-            <a:ext cx="828632" cy="104140"/>
+            <a:ext cx="1027823" cy="104140"/>
           </a:xfrm>
           <a:prstGeom prst="rect">
             <a:avLst/>
@@ -5832,7 +6452,27 @@
       </p:sp>
       <p:sp>
         <p:nvSpPr>
-          <p:cNvPr id="143" name="Text 141"/>
+          <p:cNvPr id="174" name="Shape 172"/>
+          <p:cNvSpPr/>
+          <p:nvPr/>
+        </p:nvSpPr>
+        <p:spPr>
+          <a:xfrm>
+            <a:off x="9739990" y="5321300"/>
+            <a:ext cx="21946" cy="166624"/>
+          </a:xfrm>
+          <a:prstGeom prst="rect">
+            <a:avLst/>
+          </a:prstGeom>
+          <a:solidFill>
+            <a:srgbClr val="0B2C4A"/>
+          </a:solidFill>
+          <a:ln/>
+        </p:spPr>
+      </p:sp>
+      <p:sp>
+        <p:nvSpPr>
+          <p:cNvPr id="175" name="Text 173"/>
           <p:cNvSpPr txBox="1"/>
           <p:nvPr/>
         </p:nvSpPr>
@@ -5871,7 +6511,7 @@
       </p:sp>
       <p:sp>
         <p:nvSpPr>
-          <p:cNvPr id="144" name="Text 142"/>
+          <p:cNvPr id="176" name="Text 174"/>
           <p:cNvSpPr txBox="1"/>
           <p:nvPr/>
         </p:nvSpPr>
@@ -5910,7 +6550,7 @@
       </p:sp>
       <p:sp>
         <p:nvSpPr>
-          <p:cNvPr id="145" name="Text 143"/>
+          <p:cNvPr id="177" name="Text 175"/>
           <p:cNvSpPr txBox="1"/>
           <p:nvPr/>
         </p:nvSpPr>
@@ -5949,14 +6589,14 @@
       </p:sp>
       <p:sp>
         <p:nvSpPr>
-          <p:cNvPr id="146" name="Shape 144"/>
+          <p:cNvPr id="178" name="Shape 176"/>
           <p:cNvSpPr/>
           <p:nvPr/>
         </p:nvSpPr>
         <p:spPr>
           <a:xfrm>
             <a:off x="8558784" y="5560822"/>
-            <a:ext cx="800888" cy="104140"/>
+            <a:ext cx="993409" cy="104140"/>
           </a:xfrm>
           <a:prstGeom prst="rect">
             <a:avLst/>
@@ -5969,7 +6609,27 @@
       </p:sp>
       <p:sp>
         <p:nvSpPr>
-          <p:cNvPr id="147" name="Text 145"/>
+          <p:cNvPr id="179" name="Shape 177"/>
+          <p:cNvSpPr/>
+          <p:nvPr/>
+        </p:nvSpPr>
+        <p:spPr>
+          <a:xfrm>
+            <a:off x="9739990" y="5529580"/>
+            <a:ext cx="21946" cy="166624"/>
+          </a:xfrm>
+          <a:prstGeom prst="rect">
+            <a:avLst/>
+          </a:prstGeom>
+          <a:solidFill>
+            <a:srgbClr val="0B2C4A"/>
+          </a:solidFill>
+          <a:ln/>
+        </p:spPr>
+      </p:sp>
+      <p:sp>
+        <p:nvSpPr>
+          <p:cNvPr id="180" name="Text 178"/>
           <p:cNvSpPr txBox="1"/>
           <p:nvPr/>
         </p:nvSpPr>
@@ -6008,7 +6668,7 @@
       </p:sp>
       <p:sp>
         <p:nvSpPr>
-          <p:cNvPr id="148" name="Shape 146"/>
+          <p:cNvPr id="181" name="Shape 179"/>
           <p:cNvSpPr/>
           <p:nvPr/>
         </p:nvSpPr>
@@ -6028,7 +6688,7 @@
       </p:sp>
       <p:sp>
         <p:nvSpPr>
-          <p:cNvPr id="149" name="Shape 147"/>
+          <p:cNvPr id="182" name="Shape 180"/>
           <p:cNvSpPr/>
           <p:nvPr/>
         </p:nvSpPr>
@@ -6048,7 +6708,7 @@
       </p:sp>
       <p:sp>
         <p:nvSpPr>
-          <p:cNvPr id="150" name="Shape 148"/>
+          <p:cNvPr id="183" name="Shape 181"/>
           <p:cNvSpPr/>
           <p:nvPr/>
         </p:nvSpPr>
@@ -6068,7 +6728,7 @@
       </p:sp>
       <p:sp>
         <p:nvSpPr>
-          <p:cNvPr id="151" name="Shape 149"/>
+          <p:cNvPr id="184" name="Shape 182"/>
           <p:cNvSpPr/>
           <p:nvPr/>
         </p:nvSpPr>
@@ -6088,7 +6748,7 @@
       </p:sp>
       <p:sp>
         <p:nvSpPr>
-          <p:cNvPr id="152" name="Text 150"/>
+          <p:cNvPr id="185" name="Text 183"/>
           <p:cNvSpPr txBox="1"/>
           <p:nvPr/>
         </p:nvSpPr>

</xml_diff>